<commit_message>
Resolve nested documents issue + Update Files
</commit_message>
<xml_diff>
--- a/thesis_colloqium/presentation_colloquium.pptx
+++ b/thesis_colloqium/presentation_colloquium.pptx
@@ -242,7 +242,7 @@
           <a:p>
             <a:fld id="{2BF4C96F-5C6D-48ED-8D42-B768302B23AD}" type="datetimeFigureOut">
               <a:rPr lang="de-CH" smtClean="0"/>
-              <a:t>29.04.2026</a:t>
+              <a:t>08.05.2026</a:t>
             </a:fld>
             <a:endParaRPr lang="de-CH"/>
           </a:p>
@@ -419,7 +419,7 @@
           <a:p>
             <a:fld id="{736D3A44-FA09-4C0A-99A6-1BA009890161}" type="datetimeFigureOut">
               <a:rPr lang="de-CH" smtClean="0"/>
-              <a:t>29.04.2026</a:t>
+              <a:t>08.05.2026</a:t>
             </a:fld>
             <a:endParaRPr lang="de-CH"/>
           </a:p>
@@ -9885,41 +9885,18 @@
 </file>
 
 <file path=customXml/item1.xml><?xml version="1.0" encoding="utf-8"?>
+<TemplafyFormConfiguration><![CDATA[{"formFields":[{"required":true,"shareValue":false,"type":"datePicker","name":"Date","label":"Datum"},{"required":false,"placeholder":"","lines":1,"shareValue":false,"type":"textBox","name":"Footer","label":"Fusszeile"},{"defaultValue":{"fixedValue":true},"shareValue":false,"type":"checkBox","name":"FooterLogo","label":"mit Logo in der Fusszeile"}],"formDataEntries":[{"name":"Date","value":"Y5Yz/bQYq2f4XxkiW9tl3w=="},{"name":"FooterLogo","value":"iTzqZGj1P6MRGUQq8ahlhA=="}]}]]></TemplafyFormConfiguration>
+</file>
+
+<file path=customXml/item2.xml><?xml version="1.0" encoding="utf-8"?>
 <TemplafySlideTemplateConfiguration><![CDATA[{"slideVersion":1,"isValidatorEnabled":false,"isLocked":false,"elementsMetadata":[{"type":"shape","elementConfiguration":{"width":"{{UserProfile.Department.REFDepartmentLogo.WidthPNGPPT}}","height":"{{UserProfile.Department.REFDepartmentLogo.HeightPNGPPT}}","image":"{{UserProfile.Department.REFDepartmentLogo.ImagePNG}}","disableUpdates":false,"type":"image"}}],"slideId":"637750113834106457","enableDocumentContentUpdater":true,"version":"2.0"}]]></TemplafySlideTemplateConfiguration>
 </file>
 
-<file path=customXml/item2.xml><?xml version="1.0" encoding="utf-8"?>
-<p:properties xmlns:p="http://schemas.microsoft.com/office/2006/metadata/properties" xmlns:xsi="http://www.w3.org/2001/XMLSchema-instance" xmlns:pc="http://schemas.microsoft.com/office/infopath/2007/PartnerControls">
-  <documentManagement/>
-</p:properties>
-</file>
-
 <file path=customXml/item3.xml><?xml version="1.0" encoding="utf-8"?>
-<TemplafySlideFormConfiguration><![CDATA[{"formFields":[],"formDataEntries":[]}]]></TemplafySlideFormConfiguration>
+<TemplafyTemplateConfiguration><![CDATA[{"elementsMetadata":[{"type":"shape","id":"d2e46a83-d883-46c6-8248-88bded2d57a6","elementConfiguration":{"binding":"{{FormatDateTime(Form.Date,Translate(\"DateFormat\"),DocumentLanguage)}}","disableUpdates":false,"type":"text"}},{"type":"shape","id":"e3bedeca-eba2-4a84-9990-56101ef3cee9","elementConfiguration":{"width":"{{UserProfile.Department.REFDepartmentLogo.WidthPNGPPTFooter}}","height":"{{UserProfile.Department.REFDepartmentLogo.HeightPNGPPTFooter}}","image":"{{UserProfile.Department.REFDepartmentLogo.ImagePNG}}","visibility":"{{IfElse(Form.FooterLogo, VisibilityType.Visible,VisibilityType.Hidden)}}","disableUpdates":false,"type":"image"}},{"type":"shape","id":"4837f63c-0db4-4fa9-bc7b-3594baaef131","elementConfiguration":{"binding":"{{Form.Footer}}","disableUpdates":false,"type":"text"}},{"type":"shape","id":"feecb5d8-c1f3-4329-b9c1-1de882865d5b","elementConfiguration":{"binding":"{{UserProfile.Department.DepartmentName}}","visibility":"{{IfElse(Form.FooterLogo, VisibilityType.Hidden,VisibilityType.Visible)}}","disableUpdates":false,"type":"text"}},{"type":"shape","id":"7362b5df-2182-4b2b-8e18-d1b13c8294c4","elementConfiguration":{"width":"{{UserProfile.Department.REFDepartmentLogo.WidthPNGPPT}}","height":"{{UserProfile.Department.REFDepartmentLogo.HeightPNGPPT}}","image":"{{UserProfile.Department.REFDepartmentLogo.ImagePNG}}","disableUpdates":false,"type":"image"}},{"type":"shape","id":"c4d6bc57-dd26-413d-bdbf-cde7be3ae1ae","elementConfiguration":{"binding":"{{UserProfile.Department.DepartmentName}} \n{{UserProfile.Department.DepartmentStreet}} {{UserProfile.Department.DepartmentStreetNumber}} \n{{UserProfile.Department.DepartmentPOBox}} {{UserProfile.Department.DepartmentCity}} \n{{UserProfile.Department.DepartmentCountry}} \n{{UserProfile.Department.DepartmentWebsite}}","disableUpdates":false,"type":"text"}},{"type":"shape","id":"19515ead-c28a-4815-a65a-d179492de843","elementConfiguration":{"width":"{{UserProfile.Department.REFDepartmentLogo.WidthPNGPPT}}","height":"{{UserProfile.Department.REFDepartmentLogo.HeightPNGPPT}}","image":"{{UserProfile.Department.REFDepartmentLogo.ImagePNG}}","disableUpdates":false,"type":"image"}},{"type":"shape","id":"41f05bbc-21e1-4783-9b6f-b01cb9f36fed","elementConfiguration":{"binding":"{{FormatDateTime(Form.Date,Translate(\"DateFormat\"),DocumentLanguage)}}","disableUpdates":false,"type":"text"}},{"type":"shape","id":"0f923ebf-ecac-4c3b-9eee-f589d83bdab6","elementConfiguration":{"width":"{{UserProfile.Department.REFDepartmentLogo.WidthPNGPPTFooter}}","height":"{{UserProfile.Department.REFDepartmentLogo.HeightPNGPPTFooter}}","image":"{{UserProfile.Department.REFDepartmentLogo.ImagePNG}}","visibility":"{{IfElse(Form.FooterLogo, VisibilityType.Visible,VisibilityType.Hidden)}}","disableUpdates":false,"type":"image"}},{"type":"shape","id":"5b06311a-71f3-44fa-a67a-e32ae7c41729","elementConfiguration":{"binding":"{{Form.Footer}}","disableUpdates":false,"type":"text"}},{"type":"shape","id":"0413ad6c-3c44-44f0-ad2b-154fcc172b88","elementConfiguration":{"binding":"{{UserProfile.Department.DepartmentName}}","visibility":"{{IfElse(Form.FooterLogo, VisibilityType.Hidden,VisibilityType.Visible)}}","disableUpdates":false,"type":"text"}},{"type":"shape","id":"09efe3d5-eb3d-4500-b6c1-2bf729e25f82","elementConfiguration":{"width":"{{UserProfile.Department.REFDepartmentLogo.WidthPNGPPT}}","height":"{{UserProfile.Department.REFDepartmentLogo.HeightPNGPPT}}","image":"{{UserProfile.Department.REFDepartmentLogo.ImagePNG}}","disableUpdates":false,"type":"image"}},{"type":"shape","id":"bd6aa52f-a13a-4cbd-9a7d-7d7eff3fc136","elementConfiguration":{"binding":"{{FormatDateTime(Form.Date,Translate(\"DateFormat\"),DocumentLanguage)}}","disableUpdates":false,"type":"text"}},{"type":"shape","id":"d628f1a3-76af-4449-b6e7-e9625273ecee","elementConfiguration":{"width":"{{UserProfile.Department.REFDepartmentLogo.WidthPNGPPT}}","height":"{{UserProfile.Department.REFDepartmentLogo.HeightPNGPPT}}","image":"{{UserProfile.Department.REFDepartmentLogo.ImagePNG}}","disableUpdates":false,"type":"image"}},{"type":"shape","id":"445dd559-ee52-4392-a1f0-cb27e24984b1","elementConfiguration":{"binding":"{{FormatDateTime(Form.Date,Translate(\"DateFormat\"),DocumentLanguage)}}","disableUpdates":false,"type":"text"}},{"type":"shape","id":"fb3a5038-76ce-4bad-916b-61d307d58f31","elementConfiguration":{"width":"{{UserProfile.Department.REFDepartmentLogo.WidthPNGPPTFooter}}","height":"{{UserProfile.Department.REFDepartmentLogo.HeightPNGPPTFooter}}","image":"{{UserProfile.Department.REFDepartmentLogo.ImagePNG}}","visibility":"{{IfElse(Form.FooterLogo, VisibilityType.Visible,VisibilityType.Hidden)}}","disableUpdates":false,"type":"image"}},{"type":"shape","id":"0b719ce3-7ff9-4812-a1c5-15a016b23dc8","elementConfiguration":{"binding":"{{Form.Footer}}","disableUpdates":false,"type":"text"}},{"type":"shape","id":"758b5a03-f70c-4c46-8805-41d1f6cb57ac","elementConfiguration":{"binding":"{{UserProfile.Department.DepartmentName}}","visibility":"{{IfElse(Form.FooterLogo, VisibilityType.Hidden,VisibilityType.Visible)}}","disableUpdates":false,"type":"text"}},{"type":"shape","id":"534e37f8-6ce5-4e83-83f7-139c4edb33b6","elementConfiguration":{"binding":"{{FormatDateTime(Form.Date,Translate(\"DateFormat\"),DocumentLanguage)}}","disableUpdates":false,"type":"text"}},{"type":"shape","id":"2d7582b5-0f6e-40c5-9616-4fb5a1f4074f","elementConfiguration":{"width":"{{UserProfile.Department.REFDepartmentLogo.WidthPNGPPTFooter}}","height":"{{UserProfile.Department.REFDepartmentLogo.HeightPNGPPTFooter}}","image":"{{UserProfile.Department.REFDepartmentLogo.ImagePNG}}","visibility":"{{IfElse(Form.FooterLogo, VisibilityType.Visible,VisibilityType.Hidden)}}","disableUpdates":false,"type":"image"}},{"type":"shape","id":"2c87faea-1a64-437a-bb7d-a71406fd4235","elementConfiguration":{"binding":"{{Form.Footer}}","disableUpdates":false,"type":"text"}},{"type":"shape","id":"cd7f4376-dfc2-434e-bc16-7ac8af2f7f41","elementConfiguration":{"binding":"{{UserProfile.Department.DepartmentName}}","visibility":"{{IfElse(Form.FooterLogo, VisibilityType.Hidden,VisibilityType.Visible)}}","disableUpdates":false,"type":"text"}},{"type":"shape","id":"c2696ea5-12d5-4400-ae44-434a113d23aa","elementConfiguration":{"binding":"{{FormatDateTime(Form.Date,Translate(\"DateFormat\"),DocumentLanguage)}}","disableUpdates":false,"type":"text"}},{"type":"shape","id":"0149e8eb-44ef-41ca-8dd5-dbfc5cc163ce","elementConfiguration":{"binding":"{{FormatDateTime(Form.Date,Translate(\"DateFormat\"),DocumentLanguage)}}","disableUpdates":false,"type":"text"}},{"type":"shape","id":"53bf07fa-8816-4ee3-befc-695b0a7137d8","elementConfiguration":{"binding":"{{Form.Footer}}","disableUpdates":false,"type":"text"}},{"type":"shape","id":"0a928257-12dc-4a17-9157-4e46e92e3a36","elementConfiguration":{"width":"{{UserProfile.Department.REFDepartmentLogo.WidthPNGPPTFooter}}","height":"{{UserProfile.Department.REFDepartmentLogo.HeightPNGPPTFooter}}","image":"{{UserProfile.Department.REFDepartmentLogo.ImagePNG}}","visibility":"{{IfElse(Form.FooterLogo, VisibilityType.Visible,VisibilityType.Hidden)}}","disableUpdates":false,"type":"image"}},{"type":"shape","id":"d0dd0247-bfa1-4889-82c6-0953b2c69054","elementConfiguration":{"binding":"{{UserProfile.Department.DepartmentName}}","visibility":"{{IfElse(Form.FooterLogo, VisibilityType.Hidden,VisibilityType.Visible)}}","disableUpdates":false,"type":"text"}},{"type":"shape","id":"a3ae8311-d734-423a-84f9-bcd2c0941847","elementConfiguration":{"binding":"{{FormatDateTime(Form.Date,Translate(\"DateFormat\"),DocumentLanguage)}}","disableUpdates":false,"type":"text"}},{"type":"shape","id":"7a436c19-af92-4287-aded-6d3e77d02c04","elementConfiguration":{"width":"{{UserProfile.Department.REFDepartmentLogo.WidthPNGPPTFooter}}","height":"{{UserProfile.Department.REFDepartmentLogo.HeightPNGPPTFooter}}","image":"{{UserProfile.Department.REFDepartmentLogo.ImagePNG}}","visibility":"{{IfElse(Form.FooterLogo, VisibilityType.Visible,VisibilityType.Hidden)}}","disableUpdates":false,"type":"image"}},{"type":"shape","id":"b19d27ff-9ea5-4779-b743-414fcc9ad840","elementConfiguration":{"binding":"{{Form.Footer}}","disableUpdates":false,"type":"text"}},{"type":"shape","id":"bd11cdc7-dd72-4c4a-8b4f-a283d597c128","elementConfiguration":{"binding":"{{UserProfile.Department.DepartmentName}}","visibility":"{{IfElse(Form.FooterLogo, VisibilityType.Hidden,VisibilityType.Visible)}}","disableUpdates":false,"type":"text"}}],"transformationConfigurations":[{"language":"{{UserProfile.DocumentLanguage.Language}}","disableUpdates":false,"type":"proofingLanguage"},{"propertyName":"creator","propertyValue":"{{UserProfile.FirstName}} {{UserProfile.LastName}}","disableUpdates":false,"type":"documentProperty"}],"templateName":"UNISG Präsentation","templateDescription":"","enableDocumentContentUpdater":true,"version":"2.0"}]]></TemplafyTemplateConfiguration>
 </file>
 
 <file path=customXml/item4.xml><?xml version="1.0" encoding="utf-8"?>
-<TemplafySlideTemplateConfiguration><![CDATA[{"slideVersion":1,"isValidatorEnabled":false,"isLocked":false,"elementsMetadata":[{"type":"shape","elementConfiguration":{"width":"{{UserProfile.Department.REFDepartmentLogo.WidthPNGPPT}}","height":"{{UserProfile.Department.REFDepartmentLogo.HeightPNGPPT}}","image":"{{UserProfile.Department.REFDepartmentLogo.ImagePNG}}","disableUpdates":false,"type":"image"}}],"slideId":"637750113834106457","enableDocumentContentUpdater":true,"version":"2.0"}]]></TemplafySlideTemplateConfiguration>
-</file>
-
-<file path=customXml/item5.xml><?xml version="1.0" encoding="utf-8"?>
-<TemplafyFormConfiguration><![CDATA[{"formFields":[{"required":true,"shareValue":false,"type":"datePicker","name":"Date","label":"Datum"},{"required":false,"placeholder":"","lines":1,"shareValue":false,"type":"textBox","name":"Footer","label":"Fusszeile"},{"defaultValue":{"fixedValue":true},"shareValue":false,"type":"checkBox","name":"FooterLogo","label":"mit Logo in der Fusszeile"}],"formDataEntries":[{"name":"Date","value":"Y5Yz/bQYq2f4XxkiW9tl3w=="},{"name":"FooterLogo","value":"iTzqZGj1P6MRGUQq8ahlhA=="}]}]]></TemplafyFormConfiguration>
-</file>
-
-<file path=customXml/item6.xml><?xml version="1.0" encoding="utf-8"?>
-<?mso-contentType ?>
-<FormTemplates xmlns="http://schemas.microsoft.com/sharepoint/v3/contenttype/forms">
-  <Display>DocumentLibraryForm</Display>
-  <Edit>DocumentLibraryForm</Edit>
-  <New>DocumentLibraryForm</New>
-</FormTemplates>
-</file>
-
-<file path=customXml/item7.xml><?xml version="1.0" encoding="utf-8"?>
-<TemplafySlideFormConfiguration><![CDATA[{"formFields":[],"formDataEntries":[]}]]></TemplafySlideFormConfiguration>
-</file>
-
-<file path=customXml/item8.xml><?xml version="1.0" encoding="utf-8"?>
 <ct:contentTypeSchema xmlns:ct="http://schemas.microsoft.com/office/2006/metadata/contentType" xmlns:ma="http://schemas.microsoft.com/office/2006/metadata/properties/metaAttributes" ct:_="" ma:_="" ma:contentTypeName="Dokument" ma:contentTypeID="0x01010034C2EED3AEDAB24AB48AF05A7A255DF4" ma:contentTypeVersion="13" ma:contentTypeDescription="Ein neues Dokument erstellen." ma:contentTypeScope="" ma:versionID="a6aaadb894dac19c584affee4fc993d6">
   <xsd:schema xmlns:xsd="http://www.w3.org/2001/XMLSchema" xmlns:xs="http://www.w3.org/2001/XMLSchema" xmlns:p="http://schemas.microsoft.com/office/2006/metadata/properties" xmlns:ns2="07c8a24f-8b40-44ca-950f-ae5db2c4fa23" xmlns:ns3="71d337dc-809a-4269-a690-d6cd31b4acd0" targetNamespace="http://schemas.microsoft.com/office/2006/metadata/properties" ma:root="true" ma:fieldsID="7db4ada0fc4504d1e5da7df171168cfe" ns2:_="" ns3:_="">
     <xsd:import namespace="07c8a24f-8b40-44ca-950f-ae5db2c4fa23"/>
@@ -10142,66 +10119,52 @@
 </ct:contentTypeSchema>
 </file>
 
+<file path=customXml/item5.xml><?xml version="1.0" encoding="utf-8"?>
+<TemplafySlideFormConfiguration><![CDATA[{"formFields":[],"formDataEntries":[]}]]></TemplafySlideFormConfiguration>
+</file>
+
+<file path=customXml/item6.xml><?xml version="1.0" encoding="utf-8"?>
+<TemplafySlideFormConfiguration><![CDATA[{"formFields":[],"formDataEntries":[]}]]></TemplafySlideFormConfiguration>
+</file>
+
+<file path=customXml/item7.xml><?xml version="1.0" encoding="utf-8"?>
+<p:properties xmlns:p="http://schemas.microsoft.com/office/2006/metadata/properties" xmlns:xsi="http://www.w3.org/2001/XMLSchema-instance" xmlns:pc="http://schemas.microsoft.com/office/infopath/2007/PartnerControls">
+  <documentManagement/>
+</p:properties>
+</file>
+
+<file path=customXml/item8.xml><?xml version="1.0" encoding="utf-8"?>
+<TemplafySlideTemplateConfiguration><![CDATA[{"slideVersion":1,"isValidatorEnabled":false,"isLocked":false,"elementsMetadata":[{"type":"shape","elementConfiguration":{"width":"{{UserProfile.Department.REFDepartmentLogo.WidthPNGPPT}}","height":"{{UserProfile.Department.REFDepartmentLogo.HeightPNGPPT}}","image":"{{UserProfile.Department.REFDepartmentLogo.ImagePNG}}","disableUpdates":false,"type":"image"}}],"slideId":"637750113834106457","enableDocumentContentUpdater":true,"version":"2.0"}]]></TemplafySlideTemplateConfiguration>
+</file>
+
 <file path=customXml/item9.xml><?xml version="1.0" encoding="utf-8"?>
-<TemplafyTemplateConfiguration><![CDATA[{"elementsMetadata":[{"type":"shape","id":"d2e46a83-d883-46c6-8248-88bded2d57a6","elementConfiguration":{"binding":"{{FormatDateTime(Form.Date,Translate(\"DateFormat\"),DocumentLanguage)}}","disableUpdates":false,"type":"text"}},{"type":"shape","id":"e3bedeca-eba2-4a84-9990-56101ef3cee9","elementConfiguration":{"width":"{{UserProfile.Department.REFDepartmentLogo.WidthPNGPPTFooter}}","height":"{{UserProfile.Department.REFDepartmentLogo.HeightPNGPPTFooter}}","image":"{{UserProfile.Department.REFDepartmentLogo.ImagePNG}}","visibility":"{{IfElse(Form.FooterLogo, VisibilityType.Visible,VisibilityType.Hidden)}}","disableUpdates":false,"type":"image"}},{"type":"shape","id":"4837f63c-0db4-4fa9-bc7b-3594baaef131","elementConfiguration":{"binding":"{{Form.Footer}}","disableUpdates":false,"type":"text"}},{"type":"shape","id":"feecb5d8-c1f3-4329-b9c1-1de882865d5b","elementConfiguration":{"binding":"{{UserProfile.Department.DepartmentName}}","visibility":"{{IfElse(Form.FooterLogo, VisibilityType.Hidden,VisibilityType.Visible)}}","disableUpdates":false,"type":"text"}},{"type":"shape","id":"7362b5df-2182-4b2b-8e18-d1b13c8294c4","elementConfiguration":{"width":"{{UserProfile.Department.REFDepartmentLogo.WidthPNGPPT}}","height":"{{UserProfile.Department.REFDepartmentLogo.HeightPNGPPT}}","image":"{{UserProfile.Department.REFDepartmentLogo.ImagePNG}}","disableUpdates":false,"type":"image"}},{"type":"shape","id":"c4d6bc57-dd26-413d-bdbf-cde7be3ae1ae","elementConfiguration":{"binding":"{{UserProfile.Department.DepartmentName}} \n{{UserProfile.Department.DepartmentStreet}} {{UserProfile.Department.DepartmentStreetNumber}} \n{{UserProfile.Department.DepartmentPOBox}} {{UserProfile.Department.DepartmentCity}} \n{{UserProfile.Department.DepartmentCountry}} \n{{UserProfile.Department.DepartmentWebsite}}","disableUpdates":false,"type":"text"}},{"type":"shape","id":"19515ead-c28a-4815-a65a-d179492de843","elementConfiguration":{"width":"{{UserProfile.Department.REFDepartmentLogo.WidthPNGPPT}}","height":"{{UserProfile.Department.REFDepartmentLogo.HeightPNGPPT}}","image":"{{UserProfile.Department.REFDepartmentLogo.ImagePNG}}","disableUpdates":false,"type":"image"}},{"type":"shape","id":"41f05bbc-21e1-4783-9b6f-b01cb9f36fed","elementConfiguration":{"binding":"{{FormatDateTime(Form.Date,Translate(\"DateFormat\"),DocumentLanguage)}}","disableUpdates":false,"type":"text"}},{"type":"shape","id":"0f923ebf-ecac-4c3b-9eee-f589d83bdab6","elementConfiguration":{"width":"{{UserProfile.Department.REFDepartmentLogo.WidthPNGPPTFooter}}","height":"{{UserProfile.Department.REFDepartmentLogo.HeightPNGPPTFooter}}","image":"{{UserProfile.Department.REFDepartmentLogo.ImagePNG}}","visibility":"{{IfElse(Form.FooterLogo, VisibilityType.Visible,VisibilityType.Hidden)}}","disableUpdates":false,"type":"image"}},{"type":"shape","id":"5b06311a-71f3-44fa-a67a-e32ae7c41729","elementConfiguration":{"binding":"{{Form.Footer}}","disableUpdates":false,"type":"text"}},{"type":"shape","id":"0413ad6c-3c44-44f0-ad2b-154fcc172b88","elementConfiguration":{"binding":"{{UserProfile.Department.DepartmentName}}","visibility":"{{IfElse(Form.FooterLogo, VisibilityType.Hidden,VisibilityType.Visible)}}","disableUpdates":false,"type":"text"}},{"type":"shape","id":"09efe3d5-eb3d-4500-b6c1-2bf729e25f82","elementConfiguration":{"width":"{{UserProfile.Department.REFDepartmentLogo.WidthPNGPPT}}","height":"{{UserProfile.Department.REFDepartmentLogo.HeightPNGPPT}}","image":"{{UserProfile.Department.REFDepartmentLogo.ImagePNG}}","disableUpdates":false,"type":"image"}},{"type":"shape","id":"bd6aa52f-a13a-4cbd-9a7d-7d7eff3fc136","elementConfiguration":{"binding":"{{FormatDateTime(Form.Date,Translate(\"DateFormat\"),DocumentLanguage)}}","disableUpdates":false,"type":"text"}},{"type":"shape","id":"d628f1a3-76af-4449-b6e7-e9625273ecee","elementConfiguration":{"width":"{{UserProfile.Department.REFDepartmentLogo.WidthPNGPPT}}","height":"{{UserProfile.Department.REFDepartmentLogo.HeightPNGPPT}}","image":"{{UserProfile.Department.REFDepartmentLogo.ImagePNG}}","disableUpdates":false,"type":"image"}},{"type":"shape","id":"445dd559-ee52-4392-a1f0-cb27e24984b1","elementConfiguration":{"binding":"{{FormatDateTime(Form.Date,Translate(\"DateFormat\"),DocumentLanguage)}}","disableUpdates":false,"type":"text"}},{"type":"shape","id":"fb3a5038-76ce-4bad-916b-61d307d58f31","elementConfiguration":{"width":"{{UserProfile.Department.REFDepartmentLogo.WidthPNGPPTFooter}}","height":"{{UserProfile.Department.REFDepartmentLogo.HeightPNGPPTFooter}}","image":"{{UserProfile.Department.REFDepartmentLogo.ImagePNG}}","visibility":"{{IfElse(Form.FooterLogo, VisibilityType.Visible,VisibilityType.Hidden)}}","disableUpdates":false,"type":"image"}},{"type":"shape","id":"0b719ce3-7ff9-4812-a1c5-15a016b23dc8","elementConfiguration":{"binding":"{{Form.Footer}}","disableUpdates":false,"type":"text"}},{"type":"shape","id":"758b5a03-f70c-4c46-8805-41d1f6cb57ac","elementConfiguration":{"binding":"{{UserProfile.Department.DepartmentName}}","visibility":"{{IfElse(Form.FooterLogo, VisibilityType.Hidden,VisibilityType.Visible)}}","disableUpdates":false,"type":"text"}},{"type":"shape","id":"534e37f8-6ce5-4e83-83f7-139c4edb33b6","elementConfiguration":{"binding":"{{FormatDateTime(Form.Date,Translate(\"DateFormat\"),DocumentLanguage)}}","disableUpdates":false,"type":"text"}},{"type":"shape","id":"2d7582b5-0f6e-40c5-9616-4fb5a1f4074f","elementConfiguration":{"width":"{{UserProfile.Department.REFDepartmentLogo.WidthPNGPPTFooter}}","height":"{{UserProfile.Department.REFDepartmentLogo.HeightPNGPPTFooter}}","image":"{{UserProfile.Department.REFDepartmentLogo.ImagePNG}}","visibility":"{{IfElse(Form.FooterLogo, VisibilityType.Visible,VisibilityType.Hidden)}}","disableUpdates":false,"type":"image"}},{"type":"shape","id":"2c87faea-1a64-437a-bb7d-a71406fd4235","elementConfiguration":{"binding":"{{Form.Footer}}","disableUpdates":false,"type":"text"}},{"type":"shape","id":"cd7f4376-dfc2-434e-bc16-7ac8af2f7f41","elementConfiguration":{"binding":"{{UserProfile.Department.DepartmentName}}","visibility":"{{IfElse(Form.FooterLogo, VisibilityType.Hidden,VisibilityType.Visible)}}","disableUpdates":false,"type":"text"}},{"type":"shape","id":"c2696ea5-12d5-4400-ae44-434a113d23aa","elementConfiguration":{"binding":"{{FormatDateTime(Form.Date,Translate(\"DateFormat\"),DocumentLanguage)}}","disableUpdates":false,"type":"text"}},{"type":"shape","id":"0149e8eb-44ef-41ca-8dd5-dbfc5cc163ce","elementConfiguration":{"binding":"{{FormatDateTime(Form.Date,Translate(\"DateFormat\"),DocumentLanguage)}}","disableUpdates":false,"type":"text"}},{"type":"shape","id":"53bf07fa-8816-4ee3-befc-695b0a7137d8","elementConfiguration":{"binding":"{{Form.Footer}}","disableUpdates":false,"type":"text"}},{"type":"shape","id":"0a928257-12dc-4a17-9157-4e46e92e3a36","elementConfiguration":{"width":"{{UserProfile.Department.REFDepartmentLogo.WidthPNGPPTFooter}}","height":"{{UserProfile.Department.REFDepartmentLogo.HeightPNGPPTFooter}}","image":"{{UserProfile.Department.REFDepartmentLogo.ImagePNG}}","visibility":"{{IfElse(Form.FooterLogo, VisibilityType.Visible,VisibilityType.Hidden)}}","disableUpdates":false,"type":"image"}},{"type":"shape","id":"d0dd0247-bfa1-4889-82c6-0953b2c69054","elementConfiguration":{"binding":"{{UserProfile.Department.DepartmentName}}","visibility":"{{IfElse(Form.FooterLogo, VisibilityType.Hidden,VisibilityType.Visible)}}","disableUpdates":false,"type":"text"}},{"type":"shape","id":"a3ae8311-d734-423a-84f9-bcd2c0941847","elementConfiguration":{"binding":"{{FormatDateTime(Form.Date,Translate(\"DateFormat\"),DocumentLanguage)}}","disableUpdates":false,"type":"text"}},{"type":"shape","id":"7a436c19-af92-4287-aded-6d3e77d02c04","elementConfiguration":{"width":"{{UserProfile.Department.REFDepartmentLogo.WidthPNGPPTFooter}}","height":"{{UserProfile.Department.REFDepartmentLogo.HeightPNGPPTFooter}}","image":"{{UserProfile.Department.REFDepartmentLogo.ImagePNG}}","visibility":"{{IfElse(Form.FooterLogo, VisibilityType.Visible,VisibilityType.Hidden)}}","disableUpdates":false,"type":"image"}},{"type":"shape","id":"b19d27ff-9ea5-4779-b743-414fcc9ad840","elementConfiguration":{"binding":"{{Form.Footer}}","disableUpdates":false,"type":"text"}},{"type":"shape","id":"bd11cdc7-dd72-4c4a-8b4f-a283d597c128","elementConfiguration":{"binding":"{{UserProfile.Department.DepartmentName}}","visibility":"{{IfElse(Form.FooterLogo, VisibilityType.Hidden,VisibilityType.Visible)}}","disableUpdates":false,"type":"text"}}],"transformationConfigurations":[{"language":"{{UserProfile.DocumentLanguage.Language}}","disableUpdates":false,"type":"proofingLanguage"},{"propertyName":"creator","propertyValue":"{{UserProfile.FirstName}} {{UserProfile.LastName}}","disableUpdates":false,"type":"documentProperty"}],"templateName":"UNISG Präsentation","templateDescription":"","enableDocumentContentUpdater":true,"version":"2.0"}]]></TemplafyTemplateConfiguration>
+<?mso-contentType ?>
+<FormTemplates xmlns="http://schemas.microsoft.com/sharepoint/v3/contenttype/forms">
+  <Display>DocumentLibraryForm</Display>
+  <Edit>DocumentLibraryForm</Edit>
+  <New>DocumentLibraryForm</New>
+</FormTemplates>
 </file>
 
 <file path=customXml/itemProps1.xml><?xml version="1.0" encoding="utf-8"?>
-<ds:datastoreItem xmlns:ds="http://schemas.openxmlformats.org/officeDocument/2006/customXml" ds:itemID="{45B06F8E-AA4D-4F38-9B8B-099300ECC694}">
+<ds:datastoreItem xmlns:ds="http://schemas.openxmlformats.org/officeDocument/2006/customXml" ds:itemID="{9BA6235D-7E1A-4B9C-ADE5-24E162A87D03}">
   <ds:schemaRefs/>
 </ds:datastoreItem>
 </file>
 
 <file path=customXml/itemProps2.xml><?xml version="1.0" encoding="utf-8"?>
-<ds:datastoreItem xmlns:ds="http://schemas.openxmlformats.org/officeDocument/2006/customXml" ds:itemID="{6567BD5C-CC0C-4648-BED2-6CE28F06E5A9}">
-  <ds:schemaRefs>
-    <ds:schemaRef ds:uri="http://purl.org/dc/terms/"/>
-    <ds:schemaRef ds:uri="http://schemas.microsoft.com/office/infopath/2007/PartnerControls"/>
-    <ds:schemaRef ds:uri="http://www.w3.org/XML/1998/namespace"/>
-    <ds:schemaRef ds:uri="http://schemas.microsoft.com/office/2006/metadata/properties"/>
-    <ds:schemaRef ds:uri="http://purl.org/dc/dcmitype/"/>
-    <ds:schemaRef ds:uri="07c8a24f-8b40-44ca-950f-ae5db2c4fa23"/>
-    <ds:schemaRef ds:uri="http://schemas.microsoft.com/office/2006/documentManagement/types"/>
-    <ds:schemaRef ds:uri="http://purl.org/dc/elements/1.1/"/>
-    <ds:schemaRef ds:uri="http://schemas.openxmlformats.org/package/2006/metadata/core-properties"/>
-    <ds:schemaRef ds:uri="71d337dc-809a-4269-a690-d6cd31b4acd0"/>
-  </ds:schemaRefs>
+<ds:datastoreItem xmlns:ds="http://schemas.openxmlformats.org/officeDocument/2006/customXml" ds:itemID="{EF512A75-4B18-4190-B37E-DEB13D66BD56}">
+  <ds:schemaRefs/>
 </ds:datastoreItem>
 </file>
 
 <file path=customXml/itemProps3.xml><?xml version="1.0" encoding="utf-8"?>
-<ds:datastoreItem xmlns:ds="http://schemas.openxmlformats.org/officeDocument/2006/customXml" ds:itemID="{A1DE4887-2FA9-49BA-B8BF-E79FB8D56958}">
+<ds:datastoreItem xmlns:ds="http://schemas.openxmlformats.org/officeDocument/2006/customXml" ds:itemID="{DD23DDCC-ABAF-42D1-9CB2-07E72D883C32}">
   <ds:schemaRefs/>
 </ds:datastoreItem>
 </file>
 
 <file path=customXml/itemProps4.xml><?xml version="1.0" encoding="utf-8"?>
-<ds:datastoreItem xmlns:ds="http://schemas.openxmlformats.org/officeDocument/2006/customXml" ds:itemID="{EF512A75-4B18-4190-B37E-DEB13D66BD56}">
-  <ds:schemaRefs/>
-</ds:datastoreItem>
-</file>
-
-<file path=customXml/itemProps5.xml><?xml version="1.0" encoding="utf-8"?>
-<ds:datastoreItem xmlns:ds="http://schemas.openxmlformats.org/officeDocument/2006/customXml" ds:itemID="{9BA6235D-7E1A-4B9C-ADE5-24E162A87D03}">
-  <ds:schemaRefs/>
-</ds:datastoreItem>
-</file>
-
-<file path=customXml/itemProps6.xml><?xml version="1.0" encoding="utf-8"?>
-<ds:datastoreItem xmlns:ds="http://schemas.openxmlformats.org/officeDocument/2006/customXml" ds:itemID="{ED2A37DE-9640-4BAD-87EB-02349D3561C8}">
-  <ds:schemaRefs>
-    <ds:schemaRef ds:uri="http://schemas.microsoft.com/sharepoint/v3/contenttype/forms"/>
-  </ds:schemaRefs>
-</ds:datastoreItem>
-</file>
-
-<file path=customXml/itemProps7.xml><?xml version="1.0" encoding="utf-8"?>
-<ds:datastoreItem xmlns:ds="http://schemas.openxmlformats.org/officeDocument/2006/customXml" ds:itemID="{B2AD1E47-E068-4DC9-B899-6D5AD12D00FA}">
-  <ds:schemaRefs/>
-</ds:datastoreItem>
-</file>
-
-<file path=customXml/itemProps8.xml><?xml version="1.0" encoding="utf-8"?>
 <ds:datastoreItem xmlns:ds="http://schemas.openxmlformats.org/officeDocument/2006/customXml" ds:itemID="{97E15B18-A30F-4D71-A1B5-E70B04E7AA69}">
   <ds:schemaRefs>
     <ds:schemaRef ds:uri="07c8a24f-8b40-44ca-950f-ae5db2c4fa23"/>
@@ -10221,9 +10184,46 @@
 </ds:datastoreItem>
 </file>
 
+<file path=customXml/itemProps5.xml><?xml version="1.0" encoding="utf-8"?>
+<ds:datastoreItem xmlns:ds="http://schemas.openxmlformats.org/officeDocument/2006/customXml" ds:itemID="{A1DE4887-2FA9-49BA-B8BF-E79FB8D56958}">
+  <ds:schemaRefs/>
+</ds:datastoreItem>
+</file>
+
+<file path=customXml/itemProps6.xml><?xml version="1.0" encoding="utf-8"?>
+<ds:datastoreItem xmlns:ds="http://schemas.openxmlformats.org/officeDocument/2006/customXml" ds:itemID="{B2AD1E47-E068-4DC9-B899-6D5AD12D00FA}">
+  <ds:schemaRefs/>
+</ds:datastoreItem>
+</file>
+
+<file path=customXml/itemProps7.xml><?xml version="1.0" encoding="utf-8"?>
+<ds:datastoreItem xmlns:ds="http://schemas.openxmlformats.org/officeDocument/2006/customXml" ds:itemID="{6567BD5C-CC0C-4648-BED2-6CE28F06E5A9}">
+  <ds:schemaRefs>
+    <ds:schemaRef ds:uri="http://purl.org/dc/terms/"/>
+    <ds:schemaRef ds:uri="http://schemas.microsoft.com/office/infopath/2007/PartnerControls"/>
+    <ds:schemaRef ds:uri="http://www.w3.org/XML/1998/namespace"/>
+    <ds:schemaRef ds:uri="http://schemas.microsoft.com/office/2006/metadata/properties"/>
+    <ds:schemaRef ds:uri="http://purl.org/dc/dcmitype/"/>
+    <ds:schemaRef ds:uri="07c8a24f-8b40-44ca-950f-ae5db2c4fa23"/>
+    <ds:schemaRef ds:uri="http://schemas.microsoft.com/office/2006/documentManagement/types"/>
+    <ds:schemaRef ds:uri="http://purl.org/dc/elements/1.1/"/>
+    <ds:schemaRef ds:uri="http://schemas.openxmlformats.org/package/2006/metadata/core-properties"/>
+    <ds:schemaRef ds:uri="71d337dc-809a-4269-a690-d6cd31b4acd0"/>
+  </ds:schemaRefs>
+</ds:datastoreItem>
+</file>
+
+<file path=customXml/itemProps8.xml><?xml version="1.0" encoding="utf-8"?>
+<ds:datastoreItem xmlns:ds="http://schemas.openxmlformats.org/officeDocument/2006/customXml" ds:itemID="{45B06F8E-AA4D-4F38-9B8B-099300ECC694}">
+  <ds:schemaRefs/>
+</ds:datastoreItem>
+</file>
+
 <file path=customXml/itemProps9.xml><?xml version="1.0" encoding="utf-8"?>
-<ds:datastoreItem xmlns:ds="http://schemas.openxmlformats.org/officeDocument/2006/customXml" ds:itemID="{DD23DDCC-ABAF-42D1-9CB2-07E72D883C32}">
-  <ds:schemaRefs/>
+<ds:datastoreItem xmlns:ds="http://schemas.openxmlformats.org/officeDocument/2006/customXml" ds:itemID="{ED2A37DE-9640-4BAD-87EB-02349D3561C8}">
+  <ds:schemaRefs>
+    <ds:schemaRef ds:uri="http://schemas.microsoft.com/sharepoint/v3/contenttype/forms"/>
+  </ds:schemaRefs>
 </ds:datastoreItem>
 </file>
 

</xml_diff>